<commit_message>
docs: align handoff package with current evidence
</commit_message>
<xml_diff>
--- a/docs/slides/RetailIQ_Flezi_Week1_Checklist_Aligned.pptx
+++ b/docs/slides/RetailIQ_Flezi_Week1_Checklist_Aligned.pptx
@@ -8377,7 +8377,7 @@
               </a:defRPr>
             </a:pPr>
             <a:r>
-              <a:t>43/43 pytest tests: SQL math, URL/key isolation, API root + 4 question flows, 8 document loaders, ROI calculations.</a:t>
+              <a:t>89 passed, 1 skipped in the latest local snapshot. Compiled graph CI and live provider checks remain unverified.</a:t>
             </a:r>
           </a:p>
         </p:txBody>
@@ -14176,7 +14176,7 @@
               </a:defRPr>
             </a:pPr>
             <a:r>
-              <a:t>VERIFIED NOW: 43 LOCAL TESTS PASS.  FULL-MODE INTEGRATION STILL NEEDS LOCAL CREDENTIAL TEST.</a:t>
+              <a:t>VERIFIED NOW: 89 PASS, 1 SKIP; CI PENDING.  FULL-MODE INTEGRATION STILL NEEDS LOCAL CREDENTIAL TEST.</a:t>
             </a:r>
           </a:p>
         </p:txBody>
@@ -15752,7 +15752,7 @@
               </a:defRPr>
             </a:pPr>
             <a:r>
-              <a:t>43 deterministic + format tests pass</a:t>
+              <a:t>89 passed; 1 skipped in local snapshot</a:t>
             </a:r>
           </a:p>
         </p:txBody>

</xml_diff>